<commit_message>
docs: dejar solo el diseno en planificacion + actualizar pitch
</commit_message>
<xml_diff>
--- a/docs/VeriBeca-Pitch.pptx
+++ b/docs/VeriBeca-Pitch.pptx
@@ -5,18 +5,18 @@
     <p:sldMasterId id="2147483648" r:id="rId1"/>
   </p:sldMasterIdLst>
   <p:sldIdLst>
-    <p:sldId id="256" r:id="rId7"/>
-    <p:sldId id="257" r:id="rId8"/>
-    <p:sldId id="258" r:id="rId9"/>
-    <p:sldId id="259" r:id="rId10"/>
-    <p:sldId id="260" r:id="rId11"/>
-    <p:sldId id="261" r:id="rId12"/>
-    <p:sldId id="262" r:id="rId13"/>
-    <p:sldId id="263" r:id="rId14"/>
-    <p:sldId id="264" r:id="rId15"/>
-    <p:sldId id="265" r:id="rId16"/>
+    <p:sldId id="256" r:id="rId2"/>
+    <p:sldId id="257" r:id="rId3"/>
+    <p:sldId id="258" r:id="rId4"/>
+    <p:sldId id="259" r:id="rId5"/>
+    <p:sldId id="260" r:id="rId6"/>
+    <p:sldId id="261" r:id="rId7"/>
+    <p:sldId id="262" r:id="rId8"/>
+    <p:sldId id="263" r:id="rId9"/>
+    <p:sldId id="264" r:id="rId10"/>
+    <p:sldId id="265" r:id="rId11"/>
   </p:sldIdLst>
-  <p:sldSz cx="12191695" cy="6858000" type="screen4x3"/>
+  <p:sldSz cx="12192000" cy="6858000"/>
   <p:notesSz cx="6858000" cy="9144000"/>
   <p:defaultTextStyle>
     <a:defPPr>
@@ -113,6 +113,22 @@
       </a:defRPr>
     </a:lvl9pPr>
   </p:defaultTextStyle>
+  <p:extLst>
+    <p:ext uri="{EFAFB233-063F-42B5-8137-9DF3F51BA10A}">
+      <p15:sldGuideLst xmlns:p15="http://schemas.microsoft.com/office/powerpoint/2012/main">
+        <p15:guide id="1" orient="horz" pos="2160">
+          <p15:clr>
+            <a:srgbClr val="A4A3A4"/>
+          </p15:clr>
+        </p15:guide>
+        <p15:guide id="2" pos="2880">
+          <p15:clr>
+            <a:srgbClr val="A4A3A4"/>
+          </p15:clr>
+        </p15:guide>
+      </p15:sldGuideLst>
+    </p:ext>
+  </p:extLst>
 </p:presentation>
 </file>
 
@@ -154,10 +170,9 @@
           <a:lstStyle/>
           <a:p>
             <a:r>
-              <a:rPr lang="en-US" smtClean="0"/>
+              <a:rPr lang="en-US"/>
               <a:t>Click to edit Master title style</a:t>
             </a:r>
-            <a:endParaRPr lang="en-US"/>
           </a:p>
         </p:txBody>
       </p:sp>
@@ -273,10 +288,9 @@
           </a:lstStyle>
           <a:p>
             <a:r>
-              <a:rPr lang="en-US" smtClean="0"/>
+              <a:rPr lang="en-US"/>
               <a:t>Click to edit Master subtitle style</a:t>
             </a:r>
-            <a:endParaRPr lang="en-US"/>
           </a:p>
         </p:txBody>
       </p:sp>
@@ -297,7 +311,7 @@
           <a:p>
             <a:fld id="{5BCAD085-E8A6-8845-BD4E-CB4CCA059FC4}" type="datetimeFigureOut">
               <a:rPr lang="en-US" smtClean="0"/>
-              <a:t>1/27/13</a:t>
+              <a:t>6/17/2026</a:t>
             </a:fld>
             <a:endParaRPr lang="en-US"/>
           </a:p>
@@ -339,7 +353,7 @@
           <a:p>
             <a:fld id="{C1FF6DA9-008F-8B48-92A6-B652298478BF}" type="slidenum">
               <a:rPr lang="en-US" smtClean="0"/>
-              <a:t>‹#›</a:t>
+              <a:t>‹Nº›</a:t>
             </a:fld>
             <a:endParaRPr lang="en-US"/>
           </a:p>
@@ -391,10 +405,9 @@
           <a:lstStyle/>
           <a:p>
             <a:r>
-              <a:rPr lang="en-US" smtClean="0"/>
+              <a:rPr lang="en-US"/>
               <a:t>Click to edit Master title style</a:t>
             </a:r>
-            <a:endParaRPr lang="en-US"/>
           </a:p>
         </p:txBody>
       </p:sp>
@@ -415,38 +428,37 @@
           <a:p>
             <a:pPr lvl="0"/>
             <a:r>
-              <a:rPr lang="en-US" smtClean="0"/>
+              <a:rPr lang="en-US"/>
               <a:t>Click to edit Master text styles</a:t>
             </a:r>
           </a:p>
           <a:p>
             <a:pPr lvl="1"/>
             <a:r>
-              <a:rPr lang="en-US" smtClean="0"/>
+              <a:rPr lang="en-US"/>
               <a:t>Second level</a:t>
             </a:r>
           </a:p>
           <a:p>
             <a:pPr lvl="2"/>
             <a:r>
-              <a:rPr lang="en-US" smtClean="0"/>
+              <a:rPr lang="en-US"/>
               <a:t>Third level</a:t>
             </a:r>
           </a:p>
           <a:p>
             <a:pPr lvl="3"/>
             <a:r>
-              <a:rPr lang="en-US" smtClean="0"/>
+              <a:rPr lang="en-US"/>
               <a:t>Fourth level</a:t>
             </a:r>
           </a:p>
           <a:p>
             <a:pPr lvl="4"/>
             <a:r>
-              <a:rPr lang="en-US" smtClean="0"/>
+              <a:rPr lang="en-US"/>
               <a:t>Fifth level</a:t>
             </a:r>
-            <a:endParaRPr lang="en-US"/>
           </a:p>
         </p:txBody>
       </p:sp>
@@ -467,7 +479,7 @@
           <a:p>
             <a:fld id="{5BCAD085-E8A6-8845-BD4E-CB4CCA059FC4}" type="datetimeFigureOut">
               <a:rPr lang="en-US" smtClean="0"/>
-              <a:t>1/27/13</a:t>
+              <a:t>6/17/2026</a:t>
             </a:fld>
             <a:endParaRPr lang="en-US"/>
           </a:p>
@@ -509,7 +521,7 @@
           <a:p>
             <a:fld id="{C1FF6DA9-008F-8B48-92A6-B652298478BF}" type="slidenum">
               <a:rPr lang="en-US" smtClean="0"/>
-              <a:t>‹#›</a:t>
+              <a:t>‹Nº›</a:t>
             </a:fld>
             <a:endParaRPr lang="en-US"/>
           </a:p>
@@ -566,10 +578,9 @@
           <a:lstStyle/>
           <a:p>
             <a:r>
-              <a:rPr lang="en-US" smtClean="0"/>
+              <a:rPr lang="en-US"/>
               <a:t>Click to edit Master title style</a:t>
             </a:r>
-            <a:endParaRPr lang="en-US"/>
           </a:p>
         </p:txBody>
       </p:sp>
@@ -595,38 +606,37 @@
           <a:p>
             <a:pPr lvl="0"/>
             <a:r>
-              <a:rPr lang="en-US" smtClean="0"/>
+              <a:rPr lang="en-US"/>
               <a:t>Click to edit Master text styles</a:t>
             </a:r>
           </a:p>
           <a:p>
             <a:pPr lvl="1"/>
             <a:r>
-              <a:rPr lang="en-US" smtClean="0"/>
+              <a:rPr lang="en-US"/>
               <a:t>Second level</a:t>
             </a:r>
           </a:p>
           <a:p>
             <a:pPr lvl="2"/>
             <a:r>
-              <a:rPr lang="en-US" smtClean="0"/>
+              <a:rPr lang="en-US"/>
               <a:t>Third level</a:t>
             </a:r>
           </a:p>
           <a:p>
             <a:pPr lvl="3"/>
             <a:r>
-              <a:rPr lang="en-US" smtClean="0"/>
+              <a:rPr lang="en-US"/>
               <a:t>Fourth level</a:t>
             </a:r>
           </a:p>
           <a:p>
             <a:pPr lvl="4"/>
             <a:r>
-              <a:rPr lang="en-US" smtClean="0"/>
+              <a:rPr lang="en-US"/>
               <a:t>Fifth level</a:t>
             </a:r>
-            <a:endParaRPr lang="en-US"/>
           </a:p>
         </p:txBody>
       </p:sp>
@@ -647,7 +657,7 @@
           <a:p>
             <a:fld id="{5BCAD085-E8A6-8845-BD4E-CB4CCA059FC4}" type="datetimeFigureOut">
               <a:rPr lang="en-US" smtClean="0"/>
-              <a:t>1/27/13</a:t>
+              <a:t>6/17/2026</a:t>
             </a:fld>
             <a:endParaRPr lang="en-US"/>
           </a:p>
@@ -689,7 +699,7 @@
           <a:p>
             <a:fld id="{C1FF6DA9-008F-8B48-92A6-B652298478BF}" type="slidenum">
               <a:rPr lang="en-US" smtClean="0"/>
-              <a:t>‹#›</a:t>
+              <a:t>‹Nº›</a:t>
             </a:fld>
             <a:endParaRPr lang="en-US"/>
           </a:p>
@@ -741,10 +751,9 @@
           <a:lstStyle/>
           <a:p>
             <a:r>
-              <a:rPr lang="en-US" smtClean="0"/>
+              <a:rPr lang="en-US"/>
               <a:t>Click to edit Master title style</a:t>
             </a:r>
-            <a:endParaRPr lang="en-US"/>
           </a:p>
         </p:txBody>
       </p:sp>
@@ -765,38 +774,37 @@
           <a:p>
             <a:pPr lvl="0"/>
             <a:r>
-              <a:rPr lang="en-US" smtClean="0"/>
+              <a:rPr lang="en-US"/>
               <a:t>Click to edit Master text styles</a:t>
             </a:r>
           </a:p>
           <a:p>
             <a:pPr lvl="1"/>
             <a:r>
-              <a:rPr lang="en-US" smtClean="0"/>
+              <a:rPr lang="en-US"/>
               <a:t>Second level</a:t>
             </a:r>
           </a:p>
           <a:p>
             <a:pPr lvl="2"/>
             <a:r>
-              <a:rPr lang="en-US" smtClean="0"/>
+              <a:rPr lang="en-US"/>
               <a:t>Third level</a:t>
             </a:r>
           </a:p>
           <a:p>
             <a:pPr lvl="3"/>
             <a:r>
-              <a:rPr lang="en-US" smtClean="0"/>
+              <a:rPr lang="en-US"/>
               <a:t>Fourth level</a:t>
             </a:r>
           </a:p>
           <a:p>
             <a:pPr lvl="4"/>
             <a:r>
-              <a:rPr lang="en-US" smtClean="0"/>
+              <a:rPr lang="en-US"/>
               <a:t>Fifth level</a:t>
             </a:r>
-            <a:endParaRPr lang="en-US"/>
           </a:p>
         </p:txBody>
       </p:sp>
@@ -817,7 +825,7 @@
           <a:p>
             <a:fld id="{5BCAD085-E8A6-8845-BD4E-CB4CCA059FC4}" type="datetimeFigureOut">
               <a:rPr lang="en-US" smtClean="0"/>
-              <a:t>1/27/13</a:t>
+              <a:t>6/17/2026</a:t>
             </a:fld>
             <a:endParaRPr lang="en-US"/>
           </a:p>
@@ -859,7 +867,7 @@
           <a:p>
             <a:fld id="{C1FF6DA9-008F-8B48-92A6-B652298478BF}" type="slidenum">
               <a:rPr lang="en-US" smtClean="0"/>
-              <a:t>‹#›</a:t>
+              <a:t>‹Nº›</a:t>
             </a:fld>
             <a:endParaRPr lang="en-US"/>
           </a:p>
@@ -920,10 +928,9 @@
           </a:lstStyle>
           <a:p>
             <a:r>
-              <a:rPr lang="en-US" smtClean="0"/>
+              <a:rPr lang="en-US"/>
               <a:t>Click to edit Master title style</a:t>
             </a:r>
-            <a:endParaRPr lang="en-US"/>
           </a:p>
         </p:txBody>
       </p:sp>
@@ -1040,7 +1047,7 @@
           <a:p>
             <a:pPr lvl="0"/>
             <a:r>
-              <a:rPr lang="en-US" smtClean="0"/>
+              <a:rPr lang="en-US"/>
               <a:t>Click to edit Master text styles</a:t>
             </a:r>
           </a:p>
@@ -1063,7 +1070,7 @@
           <a:p>
             <a:fld id="{5BCAD085-E8A6-8845-BD4E-CB4CCA059FC4}" type="datetimeFigureOut">
               <a:rPr lang="en-US" smtClean="0"/>
-              <a:t>1/27/13</a:t>
+              <a:t>6/17/2026</a:t>
             </a:fld>
             <a:endParaRPr lang="en-US"/>
           </a:p>
@@ -1105,7 +1112,7 @@
           <a:p>
             <a:fld id="{C1FF6DA9-008F-8B48-92A6-B652298478BF}" type="slidenum">
               <a:rPr lang="en-US" smtClean="0"/>
-              <a:t>‹#›</a:t>
+              <a:t>‹Nº›</a:t>
             </a:fld>
             <a:endParaRPr lang="en-US"/>
           </a:p>
@@ -1157,10 +1164,9 @@
           <a:lstStyle/>
           <a:p>
             <a:r>
-              <a:rPr lang="en-US" smtClean="0"/>
+              <a:rPr lang="en-US"/>
               <a:t>Click to edit Master title style</a:t>
             </a:r>
-            <a:endParaRPr lang="en-US"/>
           </a:p>
         </p:txBody>
       </p:sp>
@@ -1214,38 +1220,37 @@
           <a:p>
             <a:pPr lvl="0"/>
             <a:r>
-              <a:rPr lang="en-US" smtClean="0"/>
+              <a:rPr lang="en-US"/>
               <a:t>Click to edit Master text styles</a:t>
             </a:r>
           </a:p>
           <a:p>
             <a:pPr lvl="1"/>
             <a:r>
-              <a:rPr lang="en-US" smtClean="0"/>
+              <a:rPr lang="en-US"/>
               <a:t>Second level</a:t>
             </a:r>
           </a:p>
           <a:p>
             <a:pPr lvl="2"/>
             <a:r>
-              <a:rPr lang="en-US" smtClean="0"/>
+              <a:rPr lang="en-US"/>
               <a:t>Third level</a:t>
             </a:r>
           </a:p>
           <a:p>
             <a:pPr lvl="3"/>
             <a:r>
-              <a:rPr lang="en-US" smtClean="0"/>
+              <a:rPr lang="en-US"/>
               <a:t>Fourth level</a:t>
             </a:r>
           </a:p>
           <a:p>
             <a:pPr lvl="4"/>
             <a:r>
-              <a:rPr lang="en-US" smtClean="0"/>
+              <a:rPr lang="en-US"/>
               <a:t>Fifth level</a:t>
             </a:r>
-            <a:endParaRPr lang="en-US"/>
           </a:p>
         </p:txBody>
       </p:sp>
@@ -1299,38 +1304,37 @@
           <a:p>
             <a:pPr lvl="0"/>
             <a:r>
-              <a:rPr lang="en-US" smtClean="0"/>
+              <a:rPr lang="en-US"/>
               <a:t>Click to edit Master text styles</a:t>
             </a:r>
           </a:p>
           <a:p>
             <a:pPr lvl="1"/>
             <a:r>
-              <a:rPr lang="en-US" smtClean="0"/>
+              <a:rPr lang="en-US"/>
               <a:t>Second level</a:t>
             </a:r>
           </a:p>
           <a:p>
             <a:pPr lvl="2"/>
             <a:r>
-              <a:rPr lang="en-US" smtClean="0"/>
+              <a:rPr lang="en-US"/>
               <a:t>Third level</a:t>
             </a:r>
           </a:p>
           <a:p>
             <a:pPr lvl="3"/>
             <a:r>
-              <a:rPr lang="en-US" smtClean="0"/>
+              <a:rPr lang="en-US"/>
               <a:t>Fourth level</a:t>
             </a:r>
           </a:p>
           <a:p>
             <a:pPr lvl="4"/>
             <a:r>
-              <a:rPr lang="en-US" smtClean="0"/>
+              <a:rPr lang="en-US"/>
               <a:t>Fifth level</a:t>
             </a:r>
-            <a:endParaRPr lang="en-US"/>
           </a:p>
         </p:txBody>
       </p:sp>
@@ -1351,7 +1355,7 @@
           <a:p>
             <a:fld id="{5BCAD085-E8A6-8845-BD4E-CB4CCA059FC4}" type="datetimeFigureOut">
               <a:rPr lang="en-US" smtClean="0"/>
-              <a:t>1/27/13</a:t>
+              <a:t>6/17/2026</a:t>
             </a:fld>
             <a:endParaRPr lang="en-US"/>
           </a:p>
@@ -1393,7 +1397,7 @@
           <a:p>
             <a:fld id="{C1FF6DA9-008F-8B48-92A6-B652298478BF}" type="slidenum">
               <a:rPr lang="en-US" smtClean="0"/>
-              <a:t>‹#›</a:t>
+              <a:t>‹Nº›</a:t>
             </a:fld>
             <a:endParaRPr lang="en-US"/>
           </a:p>
@@ -1449,10 +1453,9 @@
           </a:lstStyle>
           <a:p>
             <a:r>
-              <a:rPr lang="en-US" smtClean="0"/>
+              <a:rPr lang="en-US"/>
               <a:t>Click to edit Master title style</a:t>
             </a:r>
-            <a:endParaRPr lang="en-US"/>
           </a:p>
         </p:txBody>
       </p:sp>
@@ -1515,7 +1518,7 @@
           <a:p>
             <a:pPr lvl="0"/>
             <a:r>
-              <a:rPr lang="en-US" smtClean="0"/>
+              <a:rPr lang="en-US"/>
               <a:t>Click to edit Master text styles</a:t>
             </a:r>
           </a:p>
@@ -1571,38 +1574,37 @@
           <a:p>
             <a:pPr lvl="0"/>
             <a:r>
-              <a:rPr lang="en-US" smtClean="0"/>
+              <a:rPr lang="en-US"/>
               <a:t>Click to edit Master text styles</a:t>
             </a:r>
           </a:p>
           <a:p>
             <a:pPr lvl="1"/>
             <a:r>
-              <a:rPr lang="en-US" smtClean="0"/>
+              <a:rPr lang="en-US"/>
               <a:t>Second level</a:t>
             </a:r>
           </a:p>
           <a:p>
             <a:pPr lvl="2"/>
             <a:r>
-              <a:rPr lang="en-US" smtClean="0"/>
+              <a:rPr lang="en-US"/>
               <a:t>Third level</a:t>
             </a:r>
           </a:p>
           <a:p>
             <a:pPr lvl="3"/>
             <a:r>
-              <a:rPr lang="en-US" smtClean="0"/>
+              <a:rPr lang="en-US"/>
               <a:t>Fourth level</a:t>
             </a:r>
           </a:p>
           <a:p>
             <a:pPr lvl="4"/>
             <a:r>
-              <a:rPr lang="en-US" smtClean="0"/>
+              <a:rPr lang="en-US"/>
               <a:t>Fifth level</a:t>
             </a:r>
-            <a:endParaRPr lang="en-US"/>
           </a:p>
         </p:txBody>
       </p:sp>
@@ -1665,7 +1667,7 @@
           <a:p>
             <a:pPr lvl="0"/>
             <a:r>
-              <a:rPr lang="en-US" smtClean="0"/>
+              <a:rPr lang="en-US"/>
               <a:t>Click to edit Master text styles</a:t>
             </a:r>
           </a:p>
@@ -1721,38 +1723,37 @@
           <a:p>
             <a:pPr lvl="0"/>
             <a:r>
-              <a:rPr lang="en-US" smtClean="0"/>
+              <a:rPr lang="en-US"/>
               <a:t>Click to edit Master text styles</a:t>
             </a:r>
           </a:p>
           <a:p>
             <a:pPr lvl="1"/>
             <a:r>
-              <a:rPr lang="en-US" smtClean="0"/>
+              <a:rPr lang="en-US"/>
               <a:t>Second level</a:t>
             </a:r>
           </a:p>
           <a:p>
             <a:pPr lvl="2"/>
             <a:r>
-              <a:rPr lang="en-US" smtClean="0"/>
+              <a:rPr lang="en-US"/>
               <a:t>Third level</a:t>
             </a:r>
           </a:p>
           <a:p>
             <a:pPr lvl="3"/>
             <a:r>
-              <a:rPr lang="en-US" smtClean="0"/>
+              <a:rPr lang="en-US"/>
               <a:t>Fourth level</a:t>
             </a:r>
           </a:p>
           <a:p>
             <a:pPr lvl="4"/>
             <a:r>
-              <a:rPr lang="en-US" smtClean="0"/>
+              <a:rPr lang="en-US"/>
               <a:t>Fifth level</a:t>
             </a:r>
-            <a:endParaRPr lang="en-US"/>
           </a:p>
         </p:txBody>
       </p:sp>
@@ -1773,7 +1774,7 @@
           <a:p>
             <a:fld id="{5BCAD085-E8A6-8845-BD4E-CB4CCA059FC4}" type="datetimeFigureOut">
               <a:rPr lang="en-US" smtClean="0"/>
-              <a:t>1/27/13</a:t>
+              <a:t>6/17/2026</a:t>
             </a:fld>
             <a:endParaRPr lang="en-US"/>
           </a:p>
@@ -1815,7 +1816,7 @@
           <a:p>
             <a:fld id="{C1FF6DA9-008F-8B48-92A6-B652298478BF}" type="slidenum">
               <a:rPr lang="en-US" smtClean="0"/>
-              <a:t>‹#›</a:t>
+              <a:t>‹Nº›</a:t>
             </a:fld>
             <a:endParaRPr lang="en-US"/>
           </a:p>
@@ -1867,10 +1868,9 @@
           <a:lstStyle/>
           <a:p>
             <a:r>
-              <a:rPr lang="en-US" smtClean="0"/>
+              <a:rPr lang="en-US"/>
               <a:t>Click to edit Master title style</a:t>
             </a:r>
-            <a:endParaRPr lang="en-US"/>
           </a:p>
         </p:txBody>
       </p:sp>
@@ -1891,7 +1891,7 @@
           <a:p>
             <a:fld id="{5BCAD085-E8A6-8845-BD4E-CB4CCA059FC4}" type="datetimeFigureOut">
               <a:rPr lang="en-US" smtClean="0"/>
-              <a:t>1/27/13</a:t>
+              <a:t>6/17/2026</a:t>
             </a:fld>
             <a:endParaRPr lang="en-US"/>
           </a:p>
@@ -1933,7 +1933,7 @@
           <a:p>
             <a:fld id="{C1FF6DA9-008F-8B48-92A6-B652298478BF}" type="slidenum">
               <a:rPr lang="en-US" smtClean="0"/>
-              <a:t>‹#›</a:t>
+              <a:t>‹Nº›</a:t>
             </a:fld>
             <a:endParaRPr lang="en-US"/>
           </a:p>
@@ -1986,7 +1986,7 @@
           <a:p>
             <a:fld id="{5BCAD085-E8A6-8845-BD4E-CB4CCA059FC4}" type="datetimeFigureOut">
               <a:rPr lang="en-US" smtClean="0"/>
-              <a:t>1/27/13</a:t>
+              <a:t>6/17/2026</a:t>
             </a:fld>
             <a:endParaRPr lang="en-US"/>
           </a:p>
@@ -2028,7 +2028,7 @@
           <a:p>
             <a:fld id="{C1FF6DA9-008F-8B48-92A6-B652298478BF}" type="slidenum">
               <a:rPr lang="en-US" smtClean="0"/>
-              <a:t>‹#›</a:t>
+              <a:t>‹Nº›</a:t>
             </a:fld>
             <a:endParaRPr lang="en-US"/>
           </a:p>
@@ -2089,10 +2089,9 @@
           </a:lstStyle>
           <a:p>
             <a:r>
-              <a:rPr lang="en-US" smtClean="0"/>
+              <a:rPr lang="en-US"/>
               <a:t>Click to edit Master title style</a:t>
             </a:r>
-            <a:endParaRPr lang="en-US"/>
           </a:p>
         </p:txBody>
       </p:sp>
@@ -2146,38 +2145,37 @@
           <a:p>
             <a:pPr lvl="0"/>
             <a:r>
-              <a:rPr lang="en-US" smtClean="0"/>
+              <a:rPr lang="en-US"/>
               <a:t>Click to edit Master text styles</a:t>
             </a:r>
           </a:p>
           <a:p>
             <a:pPr lvl="1"/>
             <a:r>
-              <a:rPr lang="en-US" smtClean="0"/>
+              <a:rPr lang="en-US"/>
               <a:t>Second level</a:t>
             </a:r>
           </a:p>
           <a:p>
             <a:pPr lvl="2"/>
             <a:r>
-              <a:rPr lang="en-US" smtClean="0"/>
+              <a:rPr lang="en-US"/>
               <a:t>Third level</a:t>
             </a:r>
           </a:p>
           <a:p>
             <a:pPr lvl="3"/>
             <a:r>
-              <a:rPr lang="en-US" smtClean="0"/>
+              <a:rPr lang="en-US"/>
               <a:t>Fourth level</a:t>
             </a:r>
           </a:p>
           <a:p>
             <a:pPr lvl="4"/>
             <a:r>
-              <a:rPr lang="en-US" smtClean="0"/>
+              <a:rPr lang="en-US"/>
               <a:t>Fifth level</a:t>
             </a:r>
-            <a:endParaRPr lang="en-US"/>
           </a:p>
         </p:txBody>
       </p:sp>
@@ -2240,7 +2238,7 @@
           <a:p>
             <a:pPr lvl="0"/>
             <a:r>
-              <a:rPr lang="en-US" smtClean="0"/>
+              <a:rPr lang="en-US"/>
               <a:t>Click to edit Master text styles</a:t>
             </a:r>
           </a:p>
@@ -2263,7 +2261,7 @@
           <a:p>
             <a:fld id="{5BCAD085-E8A6-8845-BD4E-CB4CCA059FC4}" type="datetimeFigureOut">
               <a:rPr lang="en-US" smtClean="0"/>
-              <a:t>1/27/13</a:t>
+              <a:t>6/17/2026</a:t>
             </a:fld>
             <a:endParaRPr lang="en-US"/>
           </a:p>
@@ -2305,7 +2303,7 @@
           <a:p>
             <a:fld id="{C1FF6DA9-008F-8B48-92A6-B652298478BF}" type="slidenum">
               <a:rPr lang="en-US" smtClean="0"/>
-              <a:t>‹#›</a:t>
+              <a:t>‹Nº›</a:t>
             </a:fld>
             <a:endParaRPr lang="en-US"/>
           </a:p>
@@ -2366,10 +2364,9 @@
           </a:lstStyle>
           <a:p>
             <a:r>
-              <a:rPr lang="en-US" smtClean="0"/>
+              <a:rPr lang="en-US"/>
               <a:t>Click to edit Master title style</a:t>
             </a:r>
-            <a:endParaRPr lang="en-US"/>
           </a:p>
         </p:txBody>
       </p:sp>
@@ -2493,7 +2490,7 @@
           <a:p>
             <a:pPr lvl="0"/>
             <a:r>
-              <a:rPr lang="en-US" smtClean="0"/>
+              <a:rPr lang="en-US"/>
               <a:t>Click to edit Master text styles</a:t>
             </a:r>
           </a:p>
@@ -2516,7 +2513,7 @@
           <a:p>
             <a:fld id="{5BCAD085-E8A6-8845-BD4E-CB4CCA059FC4}" type="datetimeFigureOut">
               <a:rPr lang="en-US" smtClean="0"/>
-              <a:t>1/27/13</a:t>
+              <a:t>6/17/2026</a:t>
             </a:fld>
             <a:endParaRPr lang="en-US"/>
           </a:p>
@@ -2558,7 +2555,7 @@
           <a:p>
             <a:fld id="{C1FF6DA9-008F-8B48-92A6-B652298478BF}" type="slidenum">
               <a:rPr lang="en-US" smtClean="0"/>
-              <a:t>‹#›</a:t>
+              <a:t>‹Nº›</a:t>
             </a:fld>
             <a:endParaRPr lang="en-US"/>
           </a:p>
@@ -2625,10 +2622,9 @@
           <a:lstStyle/>
           <a:p>
             <a:r>
-              <a:rPr lang="en-US" smtClean="0"/>
+              <a:rPr lang="en-US"/>
               <a:t>Click to edit Master title style</a:t>
             </a:r>
-            <a:endParaRPr lang="en-US"/>
           </a:p>
         </p:txBody>
       </p:sp>
@@ -2659,38 +2655,37 @@
           <a:p>
             <a:pPr lvl="0"/>
             <a:r>
-              <a:rPr lang="en-US" smtClean="0"/>
+              <a:rPr lang="en-US"/>
               <a:t>Click to edit Master text styles</a:t>
             </a:r>
           </a:p>
           <a:p>
             <a:pPr lvl="1"/>
             <a:r>
-              <a:rPr lang="en-US" smtClean="0"/>
+              <a:rPr lang="en-US"/>
               <a:t>Second level</a:t>
             </a:r>
           </a:p>
           <a:p>
             <a:pPr lvl="2"/>
             <a:r>
-              <a:rPr lang="en-US" smtClean="0"/>
+              <a:rPr lang="en-US"/>
               <a:t>Third level</a:t>
             </a:r>
           </a:p>
           <a:p>
             <a:pPr lvl="3"/>
             <a:r>
-              <a:rPr lang="en-US" smtClean="0"/>
+              <a:rPr lang="en-US"/>
               <a:t>Fourth level</a:t>
             </a:r>
           </a:p>
           <a:p>
             <a:pPr lvl="4"/>
             <a:r>
-              <a:rPr lang="en-US" smtClean="0"/>
+              <a:rPr lang="en-US"/>
               <a:t>Fifth level</a:t>
             </a:r>
-            <a:endParaRPr lang="en-US"/>
           </a:p>
         </p:txBody>
       </p:sp>
@@ -2729,7 +2724,7 @@
           <a:p>
             <a:fld id="{5BCAD085-E8A6-8845-BD4E-CB4CCA059FC4}" type="datetimeFigureOut">
               <a:rPr lang="en-US" smtClean="0"/>
-              <a:t>1/27/13</a:t>
+              <a:t>6/17/2026</a:t>
             </a:fld>
             <a:endParaRPr lang="en-US"/>
           </a:p>
@@ -2807,7 +2802,7 @@
           <a:p>
             <a:fld id="{C1FF6DA9-008F-8B48-92A6-B652298478BF}" type="slidenum">
               <a:rPr lang="en-US" smtClean="0"/>
-              <a:t>‹#›</a:t>
+              <a:t>‹Nº›</a:t>
             </a:fld>
             <a:endParaRPr lang="en-US"/>
           </a:p>
@@ -3088,7 +3083,7 @@
 </file>
 
 <file path=ppt/slides/slide1.xml><?xml version="1.0" encoding="utf-8"?>
-<p:sld xmlns:a="http://schemas.openxmlformats.org/drawingml/2006/main" xmlns:p="http://schemas.openxmlformats.org/presentationml/2006/main" xmlns:r="http://schemas.openxmlformats.org/officeDocument/2006/relationships">
+<p:sld xmlns:a="http://schemas.openxmlformats.org/drawingml/2006/main" xmlns:r="http://schemas.openxmlformats.org/officeDocument/2006/relationships" xmlns:p="http://schemas.openxmlformats.org/presentationml/2006/main">
   <p:cSld>
     <p:bg>
       <p:bgPr>
@@ -3104,7 +3099,14 @@
         <p:cNvGrpSpPr/>
         <p:nvPr/>
       </p:nvGrpSpPr>
-      <p:grpSpPr/>
+      <p:grpSpPr>
+        <a:xfrm>
+          <a:off x="0" y="0"/>
+          <a:ext cx="0" cy="0"/>
+          <a:chOff x="0" y="0"/>
+          <a:chExt cx="0" cy="0"/>
+        </a:xfrm>
+      </p:grpSpPr>
       <p:sp>
         <p:nvSpPr>
           <p:cNvPr id="2" name="Rectangle 1"/>
@@ -3146,6 +3148,7 @@
           <a:lstStyle/>
           <a:p>
             <a:pPr algn="ctr"/>
+            <a:endParaRPr/>
           </a:p>
         </p:txBody>
       </p:sp>
@@ -3190,6 +3193,7 @@
           <a:lstStyle/>
           <a:p>
             <a:pPr algn="ctr"/>
+            <a:endParaRPr/>
           </a:p>
         </p:txBody>
       </p:sp>
@@ -3374,7 +3378,7 @@
 </file>
 
 <file path=ppt/slides/slide10.xml><?xml version="1.0" encoding="utf-8"?>
-<p:sld xmlns:a="http://schemas.openxmlformats.org/drawingml/2006/main" xmlns:p="http://schemas.openxmlformats.org/presentationml/2006/main" xmlns:r="http://schemas.openxmlformats.org/officeDocument/2006/relationships">
+<p:sld xmlns:a="http://schemas.openxmlformats.org/drawingml/2006/main" xmlns:r="http://schemas.openxmlformats.org/officeDocument/2006/relationships" xmlns:p="http://schemas.openxmlformats.org/presentationml/2006/main">
   <p:cSld>
     <p:bg>
       <p:bgPr>
@@ -3390,7 +3394,14 @@
         <p:cNvGrpSpPr/>
         <p:nvPr/>
       </p:nvGrpSpPr>
-      <p:grpSpPr/>
+      <p:grpSpPr>
+        <a:xfrm>
+          <a:off x="0" y="0"/>
+          <a:ext cx="0" cy="0"/>
+          <a:chOff x="0" y="0"/>
+          <a:chExt cx="0" cy="0"/>
+        </a:xfrm>
+      </p:grpSpPr>
       <p:sp>
         <p:nvSpPr>
           <p:cNvPr id="2" name="Rectangle 1"/>
@@ -3432,6 +3443,7 @@
           <a:lstStyle/>
           <a:p>
             <a:pPr algn="ctr"/>
+            <a:endParaRPr/>
           </a:p>
         </p:txBody>
       </p:sp>
@@ -3476,6 +3488,7 @@
           <a:lstStyle/>
           <a:p>
             <a:pPr algn="ctr"/>
+            <a:endParaRPr/>
           </a:p>
         </p:txBody>
       </p:sp>
@@ -3582,7 +3595,7 @@
         <p:spPr>
           <a:xfrm>
             <a:off x="914400" y="5852160"/>
-            <a:ext cx="10332720" cy="548640"/>
+            <a:ext cx="10332720" cy="323165"/>
           </a:xfrm>
           <a:prstGeom prst="rect">
             <a:avLst/>
@@ -3601,13 +3614,13 @@
               </a:spcAft>
             </a:pPr>
             <a:r>
-              <a:rPr sz="1500" b="1">
+              <a:rPr sz="1500" b="1" dirty="0">
                 <a:solidFill>
                   <a:srgbClr val="E7FBF8"/>
                 </a:solidFill>
                 <a:latin typeface="Calibri"/>
               </a:rPr>
-              <a:t>github.com/santivicente/veribeca   ·   ¡Gracias!</a:t>
+              <a:t>¡Gracias!</a:t>
             </a:r>
           </a:p>
         </p:txBody>
@@ -3621,7 +3634,7 @@
 </file>
 
 <file path=ppt/slides/slide2.xml><?xml version="1.0" encoding="utf-8"?>
-<p:sld xmlns:a="http://schemas.openxmlformats.org/drawingml/2006/main" xmlns:p="http://schemas.openxmlformats.org/presentationml/2006/main" xmlns:r="http://schemas.openxmlformats.org/officeDocument/2006/relationships">
+<p:sld xmlns:a="http://schemas.openxmlformats.org/drawingml/2006/main" xmlns:r="http://schemas.openxmlformats.org/officeDocument/2006/relationships" xmlns:p="http://schemas.openxmlformats.org/presentationml/2006/main">
   <p:cSld>
     <p:bg>
       <p:bgPr>
@@ -3637,7 +3650,14 @@
         <p:cNvGrpSpPr/>
         <p:nvPr/>
       </p:nvGrpSpPr>
-      <p:grpSpPr/>
+      <p:grpSpPr>
+        <a:xfrm>
+          <a:off x="0" y="0"/>
+          <a:ext cx="0" cy="0"/>
+          <a:chOff x="0" y="0"/>
+          <a:chExt cx="0" cy="0"/>
+        </a:xfrm>
+      </p:grpSpPr>
       <p:sp>
         <p:nvSpPr>
           <p:cNvPr id="2" name="Rectangle 1"/>
@@ -3679,6 +3699,7 @@
           <a:lstStyle/>
           <a:p>
             <a:pPr algn="ctr"/>
+            <a:endParaRPr/>
           </a:p>
         </p:txBody>
       </p:sp>
@@ -3723,6 +3744,7 @@
           <a:lstStyle/>
           <a:p>
             <a:pPr algn="ctr"/>
+            <a:endParaRPr/>
           </a:p>
         </p:txBody>
       </p:sp>
@@ -4073,6 +4095,7 @@
           <a:lstStyle/>
           <a:p>
             <a:pPr algn="ctr"/>
+            <a:endParaRPr/>
           </a:p>
         </p:txBody>
       </p:sp>
@@ -4140,7 +4163,7 @@
 </file>
 
 <file path=ppt/slides/slide3.xml><?xml version="1.0" encoding="utf-8"?>
-<p:sld xmlns:a="http://schemas.openxmlformats.org/drawingml/2006/main" xmlns:p="http://schemas.openxmlformats.org/presentationml/2006/main" xmlns:r="http://schemas.openxmlformats.org/officeDocument/2006/relationships">
+<p:sld xmlns:a="http://schemas.openxmlformats.org/drawingml/2006/main" xmlns:r="http://schemas.openxmlformats.org/officeDocument/2006/relationships" xmlns:p="http://schemas.openxmlformats.org/presentationml/2006/main">
   <p:cSld>
     <p:bg>
       <p:bgPr>
@@ -4156,7 +4179,14 @@
         <p:cNvGrpSpPr/>
         <p:nvPr/>
       </p:nvGrpSpPr>
-      <p:grpSpPr/>
+      <p:grpSpPr>
+        <a:xfrm>
+          <a:off x="0" y="0"/>
+          <a:ext cx="0" cy="0"/>
+          <a:chOff x="0" y="0"/>
+          <a:chExt cx="0" cy="0"/>
+        </a:xfrm>
+      </p:grpSpPr>
       <p:sp>
         <p:nvSpPr>
           <p:cNvPr id="2" name="Rectangle 1"/>
@@ -4198,6 +4228,7 @@
           <a:lstStyle/>
           <a:p>
             <a:pPr algn="ctr"/>
+            <a:endParaRPr/>
           </a:p>
         </p:txBody>
       </p:sp>
@@ -4242,6 +4273,7 @@
           <a:lstStyle/>
           <a:p>
             <a:pPr algn="ctr"/>
+            <a:endParaRPr/>
           </a:p>
         </p:txBody>
       </p:sp>
@@ -4438,7 +4470,7 @@
           </a:fontRef>
         </p:style>
         <p:txBody>
-          <a:bodyPr rtlCol="0" anchor="ctr" wrap="square"/>
+          <a:bodyPr wrap="square" rtlCol="0" anchor="ctr"/>
           <a:lstStyle/>
           <a:p>
             <a:pPr algn="ctr">
@@ -4543,7 +4575,7 @@
           </a:fontRef>
         </p:style>
         <p:txBody>
-          <a:bodyPr rtlCol="0" anchor="ctr" wrap="square"/>
+          <a:bodyPr wrap="square" rtlCol="0" anchor="ctr"/>
           <a:lstStyle/>
           <a:p>
             <a:pPr algn="ctr">
@@ -4648,7 +4680,7 @@
           </a:fontRef>
         </p:style>
         <p:txBody>
-          <a:bodyPr rtlCol="0" anchor="ctr" wrap="square"/>
+          <a:bodyPr wrap="square" rtlCol="0" anchor="ctr"/>
           <a:lstStyle/>
           <a:p>
             <a:pPr algn="ctr">
@@ -4753,7 +4785,7 @@
           </a:fontRef>
         </p:style>
         <p:txBody>
-          <a:bodyPr rtlCol="0" anchor="ctr" wrap="square"/>
+          <a:bodyPr wrap="square" rtlCol="0" anchor="ctr"/>
           <a:lstStyle/>
           <a:p>
             <a:pPr algn="ctr">
@@ -4858,7 +4890,7 @@
           </a:fontRef>
         </p:style>
         <p:txBody>
-          <a:bodyPr rtlCol="0" anchor="ctr" wrap="square"/>
+          <a:bodyPr wrap="square" rtlCol="0" anchor="ctr"/>
           <a:lstStyle/>
           <a:p>
             <a:pPr algn="ctr">
@@ -4935,7 +4967,7 @@
 </file>
 
 <file path=ppt/slides/slide4.xml><?xml version="1.0" encoding="utf-8"?>
-<p:sld xmlns:a="http://schemas.openxmlformats.org/drawingml/2006/main" xmlns:p="http://schemas.openxmlformats.org/presentationml/2006/main" xmlns:r="http://schemas.openxmlformats.org/officeDocument/2006/relationships">
+<p:sld xmlns:a="http://schemas.openxmlformats.org/drawingml/2006/main" xmlns:r="http://schemas.openxmlformats.org/officeDocument/2006/relationships" xmlns:p="http://schemas.openxmlformats.org/presentationml/2006/main">
   <p:cSld>
     <p:bg>
       <p:bgPr>
@@ -4951,7 +4983,14 @@
         <p:cNvGrpSpPr/>
         <p:nvPr/>
       </p:nvGrpSpPr>
-      <p:grpSpPr/>
+      <p:grpSpPr>
+        <a:xfrm>
+          <a:off x="0" y="0"/>
+          <a:ext cx="0" cy="0"/>
+          <a:chOff x="0" y="0"/>
+          <a:chExt cx="0" cy="0"/>
+        </a:xfrm>
+      </p:grpSpPr>
       <p:sp>
         <p:nvSpPr>
           <p:cNvPr id="2" name="Rectangle 1"/>
@@ -4993,6 +5032,7 @@
           <a:lstStyle/>
           <a:p>
             <a:pPr algn="ctr"/>
+            <a:endParaRPr/>
           </a:p>
         </p:txBody>
       </p:sp>
@@ -5037,6 +5077,7 @@
           <a:lstStyle/>
           <a:p>
             <a:pPr algn="ctr"/>
+            <a:endParaRPr/>
           </a:p>
         </p:txBody>
       </p:sp>
@@ -5233,7 +5274,7 @@
           </a:fontRef>
         </p:style>
         <p:txBody>
-          <a:bodyPr rtlCol="0" anchor="ctr" wrap="square"/>
+          <a:bodyPr wrap="square" rtlCol="0" anchor="ctr"/>
           <a:lstStyle/>
           <a:p>
             <a:pPr algn="ctr">
@@ -5410,7 +5451,7 @@
 </file>
 
 <file path=ppt/slides/slide5.xml><?xml version="1.0" encoding="utf-8"?>
-<p:sld xmlns:a="http://schemas.openxmlformats.org/drawingml/2006/main" xmlns:p="http://schemas.openxmlformats.org/presentationml/2006/main" xmlns:r="http://schemas.openxmlformats.org/officeDocument/2006/relationships">
+<p:sld xmlns:a="http://schemas.openxmlformats.org/drawingml/2006/main" xmlns:r="http://schemas.openxmlformats.org/officeDocument/2006/relationships" xmlns:p="http://schemas.openxmlformats.org/presentationml/2006/main">
   <p:cSld>
     <p:bg>
       <p:bgPr>
@@ -5426,7 +5467,14 @@
         <p:cNvGrpSpPr/>
         <p:nvPr/>
       </p:nvGrpSpPr>
-      <p:grpSpPr/>
+      <p:grpSpPr>
+        <a:xfrm>
+          <a:off x="0" y="0"/>
+          <a:ext cx="0" cy="0"/>
+          <a:chOff x="0" y="0"/>
+          <a:chExt cx="0" cy="0"/>
+        </a:xfrm>
+      </p:grpSpPr>
       <p:sp>
         <p:nvSpPr>
           <p:cNvPr id="2" name="Rectangle 1"/>
@@ -5468,6 +5516,7 @@
           <a:lstStyle/>
           <a:p>
             <a:pPr algn="ctr"/>
+            <a:endParaRPr/>
           </a:p>
         </p:txBody>
       </p:sp>
@@ -5512,6 +5561,7 @@
           <a:lstStyle/>
           <a:p>
             <a:pPr algn="ctr"/>
+            <a:endParaRPr/>
           </a:p>
         </p:txBody>
       </p:sp>
@@ -5712,6 +5762,7 @@
           <a:lstStyle/>
           <a:p>
             <a:pPr algn="ctr"/>
+            <a:endParaRPr/>
           </a:p>
         </p:txBody>
       </p:sp>
@@ -5795,6 +5846,7 @@
           <a:lstStyle/>
           <a:p>
             <a:pPr algn="ctr"/>
+            <a:endParaRPr/>
           </a:p>
         </p:txBody>
       </p:sp>
@@ -5839,6 +5891,7 @@
           <a:lstStyle/>
           <a:p>
             <a:pPr algn="ctr"/>
+            <a:endParaRPr/>
           </a:p>
         </p:txBody>
       </p:sp>
@@ -5922,6 +5975,7 @@
           <a:lstStyle/>
           <a:p>
             <a:pPr algn="ctr"/>
+            <a:endParaRPr/>
           </a:p>
         </p:txBody>
       </p:sp>
@@ -5968,6 +6022,7 @@
           <a:lstStyle/>
           <a:p>
             <a:pPr algn="ctr"/>
+            <a:endParaRPr/>
           </a:p>
         </p:txBody>
       </p:sp>
@@ -6083,6 +6138,7 @@
           <a:lstStyle/>
           <a:p>
             <a:pPr algn="ctr"/>
+            <a:endParaRPr/>
           </a:p>
         </p:txBody>
       </p:sp>
@@ -6129,6 +6185,7 @@
           <a:lstStyle/>
           <a:p>
             <a:pPr algn="ctr"/>
+            <a:endParaRPr/>
           </a:p>
         </p:txBody>
       </p:sp>
@@ -6244,6 +6301,7 @@
           <a:lstStyle/>
           <a:p>
             <a:pPr algn="ctr"/>
+            <a:endParaRPr/>
           </a:p>
         </p:txBody>
       </p:sp>
@@ -6290,6 +6348,7 @@
           <a:lstStyle/>
           <a:p>
             <a:pPr algn="ctr"/>
+            <a:endParaRPr/>
           </a:p>
         </p:txBody>
       </p:sp>
@@ -6373,7 +6432,7 @@
 </file>
 
 <file path=ppt/slides/slide6.xml><?xml version="1.0" encoding="utf-8"?>
-<p:sld xmlns:a="http://schemas.openxmlformats.org/drawingml/2006/main" xmlns:p="http://schemas.openxmlformats.org/presentationml/2006/main" xmlns:r="http://schemas.openxmlformats.org/officeDocument/2006/relationships">
+<p:sld xmlns:a="http://schemas.openxmlformats.org/drawingml/2006/main" xmlns:r="http://schemas.openxmlformats.org/officeDocument/2006/relationships" xmlns:p="http://schemas.openxmlformats.org/presentationml/2006/main">
   <p:cSld>
     <p:bg>
       <p:bgPr>
@@ -6389,7 +6448,14 @@
         <p:cNvGrpSpPr/>
         <p:nvPr/>
       </p:nvGrpSpPr>
-      <p:grpSpPr/>
+      <p:grpSpPr>
+        <a:xfrm>
+          <a:off x="0" y="0"/>
+          <a:ext cx="0" cy="0"/>
+          <a:chOff x="0" y="0"/>
+          <a:chExt cx="0" cy="0"/>
+        </a:xfrm>
+      </p:grpSpPr>
       <p:sp>
         <p:nvSpPr>
           <p:cNvPr id="2" name="Rectangle 1"/>
@@ -6431,6 +6497,7 @@
           <a:lstStyle/>
           <a:p>
             <a:pPr algn="ctr"/>
+            <a:endParaRPr/>
           </a:p>
         </p:txBody>
       </p:sp>
@@ -6475,6 +6542,7 @@
           <a:lstStyle/>
           <a:p>
             <a:pPr algn="ctr"/>
+            <a:endParaRPr/>
           </a:p>
         </p:txBody>
       </p:sp>
@@ -6653,8 +6721,20 @@
                 <a:tableStyleId>{5C22544A-7EE6-4342-B048-85BDC9FD1C3A}</a:tableStyleId>
               </a:tblPr>
               <a:tblGrid>
-                <a:gridCol w="3840480"/>
-                <a:gridCol w="6492240"/>
+                <a:gridCol w="3840480">
+                  <a:extLst>
+                    <a:ext uri="{9D8B030D-6E8A-4147-A177-3AD203B41FA5}">
+                      <a16:colId xmlns:a16="http://schemas.microsoft.com/office/drawing/2014/main" val="20000"/>
+                    </a:ext>
+                  </a:extLst>
+                </a:gridCol>
+                <a:gridCol w="6492240">
+                  <a:extLst>
+                    <a:ext uri="{9D8B030D-6E8A-4147-A177-3AD203B41FA5}">
+                      <a16:colId xmlns:a16="http://schemas.microsoft.com/office/drawing/2014/main" val="20001"/>
+                    </a:ext>
+                  </a:extLst>
+                </a:gridCol>
               </a:tblGrid>
               <a:tr h="670560">
                 <a:tc>
@@ -6701,6 +6781,11 @@
                     </a:solidFill>
                   </a:tcPr>
                 </a:tc>
+                <a:extLst>
+                  <a:ext uri="{0D108BD9-81ED-4DB2-BD59-A6C34878D82A}">
+                    <a16:rowId xmlns:a16="http://schemas.microsoft.com/office/drawing/2014/main" val="10000"/>
+                  </a:ext>
+                </a:extLst>
               </a:tr>
               <a:tr h="670560">
                 <a:tc>
@@ -6747,6 +6832,11 @@
                     </a:solidFill>
                   </a:tcPr>
                 </a:tc>
+                <a:extLst>
+                  <a:ext uri="{0D108BD9-81ED-4DB2-BD59-A6C34878D82A}">
+                    <a16:rowId xmlns:a16="http://schemas.microsoft.com/office/drawing/2014/main" val="10001"/>
+                  </a:ext>
+                </a:extLst>
               </a:tr>
               <a:tr h="670560">
                 <a:tc>
@@ -6793,6 +6883,11 @@
                     </a:solidFill>
                   </a:tcPr>
                 </a:tc>
+                <a:extLst>
+                  <a:ext uri="{0D108BD9-81ED-4DB2-BD59-A6C34878D82A}">
+                    <a16:rowId xmlns:a16="http://schemas.microsoft.com/office/drawing/2014/main" val="10002"/>
+                  </a:ext>
+                </a:extLst>
               </a:tr>
               <a:tr h="670560">
                 <a:tc>
@@ -6839,6 +6934,11 @@
                     </a:solidFill>
                   </a:tcPr>
                 </a:tc>
+                <a:extLst>
+                  <a:ext uri="{0D108BD9-81ED-4DB2-BD59-A6C34878D82A}">
+                    <a16:rowId xmlns:a16="http://schemas.microsoft.com/office/drawing/2014/main" val="10003"/>
+                  </a:ext>
+                </a:extLst>
               </a:tr>
               <a:tr h="670560">
                 <a:tc>
@@ -6885,6 +6985,11 @@
                     </a:solidFill>
                   </a:tcPr>
                 </a:tc>
+                <a:extLst>
+                  <a:ext uri="{0D108BD9-81ED-4DB2-BD59-A6C34878D82A}">
+                    <a16:rowId xmlns:a16="http://schemas.microsoft.com/office/drawing/2014/main" val="10004"/>
+                  </a:ext>
+                </a:extLst>
               </a:tr>
               <a:tr h="670560">
                 <a:tc>
@@ -6931,6 +7036,11 @@
                     </a:solidFill>
                   </a:tcPr>
                 </a:tc>
+                <a:extLst>
+                  <a:ext uri="{0D108BD9-81ED-4DB2-BD59-A6C34878D82A}">
+                    <a16:rowId xmlns:a16="http://schemas.microsoft.com/office/drawing/2014/main" val="10005"/>
+                  </a:ext>
+                </a:extLst>
               </a:tr>
             </a:tbl>
           </a:graphicData>
@@ -6945,7 +7055,7 @@
 </file>
 
 <file path=ppt/slides/slide7.xml><?xml version="1.0" encoding="utf-8"?>
-<p:sld xmlns:a="http://schemas.openxmlformats.org/drawingml/2006/main" xmlns:p="http://schemas.openxmlformats.org/presentationml/2006/main" xmlns:r="http://schemas.openxmlformats.org/officeDocument/2006/relationships">
+<p:sld xmlns:a="http://schemas.openxmlformats.org/drawingml/2006/main" xmlns:r="http://schemas.openxmlformats.org/officeDocument/2006/relationships" xmlns:p="http://schemas.openxmlformats.org/presentationml/2006/main">
   <p:cSld>
     <p:bg>
       <p:bgPr>
@@ -6961,7 +7071,14 @@
         <p:cNvGrpSpPr/>
         <p:nvPr/>
       </p:nvGrpSpPr>
-      <p:grpSpPr/>
+      <p:grpSpPr>
+        <a:xfrm>
+          <a:off x="0" y="0"/>
+          <a:ext cx="0" cy="0"/>
+          <a:chOff x="0" y="0"/>
+          <a:chExt cx="0" cy="0"/>
+        </a:xfrm>
+      </p:grpSpPr>
       <p:sp>
         <p:nvSpPr>
           <p:cNvPr id="2" name="Rectangle 1"/>
@@ -7003,6 +7120,7 @@
           <a:lstStyle/>
           <a:p>
             <a:pPr algn="ctr"/>
+            <a:endParaRPr/>
           </a:p>
         </p:txBody>
       </p:sp>
@@ -7047,6 +7165,7 @@
           <a:lstStyle/>
           <a:p>
             <a:pPr algn="ctr"/>
+            <a:endParaRPr/>
           </a:p>
         </p:txBody>
       </p:sp>
@@ -7249,6 +7368,7 @@
           <a:lstStyle/>
           <a:p>
             <a:pPr algn="ctr"/>
+            <a:endParaRPr/>
           </a:p>
         </p:txBody>
       </p:sp>
@@ -7293,6 +7413,7 @@
           <a:lstStyle/>
           <a:p>
             <a:pPr algn="ctr"/>
+            <a:endParaRPr/>
           </a:p>
         </p:txBody>
       </p:sp>
@@ -7394,6 +7515,7 @@
           <a:lstStyle/>
           <a:p>
             <a:pPr algn="ctr"/>
+            <a:endParaRPr/>
           </a:p>
         </p:txBody>
       </p:sp>
@@ -7438,6 +7560,7 @@
           <a:lstStyle/>
           <a:p>
             <a:pPr algn="ctr"/>
+            <a:endParaRPr/>
           </a:p>
         </p:txBody>
       </p:sp>
@@ -7539,6 +7662,7 @@
           <a:lstStyle/>
           <a:p>
             <a:pPr algn="ctr"/>
+            <a:endParaRPr/>
           </a:p>
         </p:txBody>
       </p:sp>
@@ -7583,6 +7707,7 @@
           <a:lstStyle/>
           <a:p>
             <a:pPr algn="ctr"/>
+            <a:endParaRPr/>
           </a:p>
         </p:txBody>
       </p:sp>
@@ -7650,7 +7775,7 @@
 </file>
 
 <file path=ppt/slides/slide8.xml><?xml version="1.0" encoding="utf-8"?>
-<p:sld xmlns:a="http://schemas.openxmlformats.org/drawingml/2006/main" xmlns:p="http://schemas.openxmlformats.org/presentationml/2006/main" xmlns:r="http://schemas.openxmlformats.org/officeDocument/2006/relationships">
+<p:sld xmlns:a="http://schemas.openxmlformats.org/drawingml/2006/main" xmlns:r="http://schemas.openxmlformats.org/officeDocument/2006/relationships" xmlns:p="http://schemas.openxmlformats.org/presentationml/2006/main">
   <p:cSld>
     <p:bg>
       <p:bgPr>
@@ -7666,7 +7791,14 @@
         <p:cNvGrpSpPr/>
         <p:nvPr/>
       </p:nvGrpSpPr>
-      <p:grpSpPr/>
+      <p:grpSpPr>
+        <a:xfrm>
+          <a:off x="0" y="0"/>
+          <a:ext cx="0" cy="0"/>
+          <a:chOff x="0" y="0"/>
+          <a:chExt cx="0" cy="0"/>
+        </a:xfrm>
+      </p:grpSpPr>
       <p:sp>
         <p:nvSpPr>
           <p:cNvPr id="2" name="Rectangle 1"/>
@@ -7708,6 +7840,7 @@
           <a:lstStyle/>
           <a:p>
             <a:pPr algn="ctr"/>
+            <a:endParaRPr/>
           </a:p>
         </p:txBody>
       </p:sp>
@@ -7752,6 +7885,7 @@
           <a:lstStyle/>
           <a:p>
             <a:pPr algn="ctr"/>
+            <a:endParaRPr/>
           </a:p>
         </p:txBody>
       </p:sp>
@@ -7952,6 +8086,7 @@
           <a:lstStyle/>
           <a:p>
             <a:pPr algn="ctr"/>
+            <a:endParaRPr/>
           </a:p>
         </p:txBody>
       </p:sp>
@@ -8067,6 +8202,7 @@
           <a:lstStyle/>
           <a:p>
             <a:pPr algn="ctr"/>
+            <a:endParaRPr/>
           </a:p>
         </p:txBody>
       </p:sp>
@@ -8182,6 +8318,7 @@
           <a:lstStyle/>
           <a:p>
             <a:pPr algn="ctr"/>
+            <a:endParaRPr/>
           </a:p>
         </p:txBody>
       </p:sp>
@@ -8297,6 +8434,7 @@
           <a:lstStyle/>
           <a:p>
             <a:pPr algn="ctr"/>
+            <a:endParaRPr/>
           </a:p>
         </p:txBody>
       </p:sp>
@@ -8478,7 +8616,7 @@
 </file>
 
 <file path=ppt/slides/slide9.xml><?xml version="1.0" encoding="utf-8"?>
-<p:sld xmlns:a="http://schemas.openxmlformats.org/drawingml/2006/main" xmlns:p="http://schemas.openxmlformats.org/presentationml/2006/main" xmlns:r="http://schemas.openxmlformats.org/officeDocument/2006/relationships">
+<p:sld xmlns:a="http://schemas.openxmlformats.org/drawingml/2006/main" xmlns:r="http://schemas.openxmlformats.org/officeDocument/2006/relationships" xmlns:p="http://schemas.openxmlformats.org/presentationml/2006/main">
   <p:cSld>
     <p:bg>
       <p:bgPr>
@@ -8494,7 +8632,14 @@
         <p:cNvGrpSpPr/>
         <p:nvPr/>
       </p:nvGrpSpPr>
-      <p:grpSpPr/>
+      <p:grpSpPr>
+        <a:xfrm>
+          <a:off x="0" y="0"/>
+          <a:ext cx="0" cy="0"/>
+          <a:chOff x="0" y="0"/>
+          <a:chExt cx="0" cy="0"/>
+        </a:xfrm>
+      </p:grpSpPr>
       <p:sp>
         <p:nvSpPr>
           <p:cNvPr id="2" name="Rectangle 1"/>
@@ -8536,6 +8681,7 @@
           <a:lstStyle/>
           <a:p>
             <a:pPr algn="ctr"/>
+            <a:endParaRPr/>
           </a:p>
         </p:txBody>
       </p:sp>
@@ -8580,6 +8726,7 @@
           <a:lstStyle/>
           <a:p>
             <a:pPr algn="ctr"/>
+            <a:endParaRPr/>
           </a:p>
         </p:txBody>
       </p:sp>
@@ -8962,6 +9109,7 @@
           <a:lstStyle/>
           <a:p>
             <a:pPr algn="ctr"/>
+            <a:endParaRPr/>
           </a:p>
         </p:txBody>
       </p:sp>

</xml_diff>